<commit_message>
Rebuild financial model bottom-up with commission scenario
Add docs/rentify-financial-model.xlsx (generated by build/financial_model.py)
with every input in its own cell: real server, email and registration prices,
3 founders on equity with a small allowance, Cambodian tax rules, and a 3%
marketplace commission upside scenario. Paying-shop numbers are unchanged from
the team model, so the market slides stay consistent.

Update the projection, growth and financial-detail draft slides to the new
figures and record the cost sources in docs/research.md.

Co-Authored-By: Claude Opus 5.5 <noreply@anthropic.com>
Claude-Session: https://claude.ai/code/session_01MF4S689Cu66DaEpymoVfar
</commit_message>
<xml_diff>
--- a/output/drafts/Rentify_v6_slide12_projection.pptx
+++ b/output/drafts/Rentify_v6_slide12_projection.pptx
@@ -273,13 +273,13 @@
                 <c:formatCode>General</c:formatCode>
                 <c:ptCount val="3"/>
                 <c:pt idx="0">
-                  <c:v>30258</c:v>
+                  <c:v>7255</c:v>
                 </c:pt>
                 <c:pt idx="1">
-                  <c:v>61879</c:v>
+                  <c:v>19039</c:v>
                 </c:pt>
                 <c:pt idx="2">
-                  <c:v>93819</c:v>
+                  <c:v>45607</c:v>
                 </c:pt>
               </c:numCache>
             </c:numRef>
@@ -832,8 +832,8 @@
             <a:r>
               <a:rPr lang="en-US" dirty="0"/>
               <a:t>[4:00–4:18]
-Our lean model counts subscriptions only. Revenue grows to 68,000 dollars in Year 3. We break even at about 1,900 paying shops — under 3% of the 65,000 specialised stores we target. Marketplace commission, once online payments launch, is upside on top.
-(Q&amp;A: the $5 average is conservative — Starter is $5 and Pro is $10; Free-plan shops pay no subscription and are not counted as paying. All inputs will be updated with pilot data.)</a:t>
+We run lean: three founders who hold equity, AI-assisted development, and cloud servers that cost about 50 dollars a month at launch. Counting subscriptions only, revenue reaches 68,000 dollars in Year 3, we turn profitable in Year 2, and we break even at about 670 paying shops — around 1% of the stores we target. Marketplace commission is upside on top.
+(Q&amp;A: founders take a small allowance, $100 rising to $500 a month; even at a $1,000 market salary, Year 3 is still about +$7.7K. We need about $3.8K before we turn profitable. Model: docs/rentify-financial-model.xlsx.)</a:t>
             </a:r>
             <a:endParaRPr lang="en-US" dirty="0"/>
           </a:p>
@@ -1278,7 +1278,7 @@
                 <a:ea typeface="Arial" pitchFamily="34" charset="-122"/>
                 <a:cs typeface="Arial" pitchFamily="34" charset="-120"/>
               </a:rPr>
-              <a:t>Subscriptions only · marketplace commission not included</a:t>
+              <a:t>Base case: subscriptions only, founders on equity · commission is upside</a:t>
             </a:r>
             <a:endParaRPr lang="en-US" sz="1500" dirty="0"/>
           </a:p>
@@ -1489,7 +1489,7 @@
                 <a:ea typeface="Arial" pitchFamily="34" charset="-122"/>
                 <a:cs typeface="Arial" pitchFamily="34" charset="-120"/>
               </a:rPr>
-              <a:t>1,895</a:t>
+              <a:t>Year 2</a:t>
             </a:r>
             <a:endParaRPr lang="en-US" sz="2600" dirty="0"/>
           </a:p>
@@ -1528,7 +1528,7 @@
                 <a:ea typeface="Arial" pitchFamily="34" charset="-122"/>
                 <a:cs typeface="Arial" pitchFamily="34" charset="-120"/>
               </a:rPr>
-              <a:t>paying shops to break even</a:t>
+              <a:t>first profit: +$6.1K</a:t>
             </a:r>
             <a:endParaRPr lang="en-US" sz="1300" dirty="0"/>
           </a:p>
@@ -1589,7 +1589,7 @@
                 <a:ea typeface="Arial" pitchFamily="34" charset="-122"/>
                 <a:cs typeface="Arial" pitchFamily="34" charset="-120"/>
               </a:rPr>
-              <a:t>2.9%</a:t>
+              <a:t>~670</a:t>
             </a:r>
             <a:endParaRPr lang="en-US" sz="2600" dirty="0"/>
           </a:p>
@@ -1628,7 +1628,7 @@
                 <a:ea typeface="Arial" pitchFamily="34" charset="-122"/>
                 <a:cs typeface="Arial" pitchFamily="34" charset="-120"/>
               </a:rPr>
-              <a:t>of our 65,400-store market</a:t>
+              <a:t>paying shops to break even (1% of our market)</a:t>
             </a:r>
             <a:endParaRPr lang="en-US" sz="1300" dirty="0"/>
           </a:p>
@@ -1689,7 +1689,7 @@
                 <a:ea typeface="Arial" pitchFamily="34" charset="-122"/>
                 <a:cs typeface="Arial" pitchFamily="34" charset="-120"/>
               </a:rPr>
-              <a:t>$5</a:t>
+              <a:t>$3.8K</a:t>
             </a:r>
             <a:endParaRPr lang="en-US" sz="2600" dirty="0"/>
           </a:p>
@@ -1728,7 +1728,7 @@
                 <a:ea typeface="Arial" pitchFamily="34" charset="-122"/>
                 <a:cs typeface="Arial" pitchFamily="34" charset="-120"/>
               </a:rPr>
-              <a:t>average plan (Starter $5, Pro $10)</a:t>
+              <a:t>funding needed before profit</a:t>
             </a:r>
             <a:endParaRPr lang="en-US" sz="1300" dirty="0"/>
           </a:p>
@@ -1767,7 +1767,7 @@
                 <a:ea typeface="Arial" pitchFamily="34" charset="-122"/>
                 <a:cs typeface="Arial" pitchFamily="34" charset="-120"/>
               </a:rPr>
-              <a:t>Team 36-month model, lean cost base. Net result −$26.8K, −$36.7K, −$26.1K (Years 1–3). Prices, conversion, churn and costs are assumptions to validate in the pilot.</a:t>
+              <a:t>Net result −$3.8K, +$6.1K, +$22.1K (Years 1–3). With 3% marketplace commission: −$3.5K, +$10.6K, +$38.4K. Costs priced bottom-up (DigitalOcean, Resend, MoC fees); shop numbers from the team model. Full detail in appendix; all inputs to validate in the pilot.</a:t>
             </a:r>
             <a:endParaRPr lang="en-US" sz="950" dirty="0"/>
           </a:p>

</xml_diff>

<commit_message>
Add Cambodian taxes and full 5-person team to financial model
Model v3: prices treated as VAT-inclusive (10%), 1% profit-tax prepayment,
20% profit tax after loss carry-forward, patent tax, NSSF, and 14%
withholding on foreign services; all 5 team members take the founder
allowance. Update projection, growth and financial-detail drafts and
document how Cambodian tax applies in docs/research.md.

Co-Authored-By: Claude Opus 5.5 <noreply@anthropic.com>
Claude-Session: https://claude.ai/code/session_01MF4S689Cu66DaEpymoVfar
</commit_message>
<xml_diff>
--- a/output/drafts/Rentify_v6_slide12_projection.pptx
+++ b/output/drafts/Rentify_v6_slide12_projection.pptx
@@ -190,13 +190,13 @@
                 <c:formatCode>General</c:formatCode>
                 <c:ptCount val="3"/>
                 <c:pt idx="0">
-                  <c:v>3456</c:v>
+                  <c:v>3142</c:v>
                 </c:pt>
                 <c:pt idx="1">
-                  <c:v>25131</c:v>
+                  <c:v>22846</c:v>
                 </c:pt>
                 <c:pt idx="2">
-                  <c:v>67744</c:v>
+                  <c:v>61586</c:v>
                 </c:pt>
               </c:numCache>
             </c:numRef>
@@ -273,13 +273,13 @@
                 <c:formatCode>General</c:formatCode>
                 <c:ptCount val="3"/>
                 <c:pt idx="0">
-                  <c:v>7255</c:v>
+                  <c:v>11212</c:v>
                 </c:pt>
                 <c:pt idx="1">
-                  <c:v>19039</c:v>
+                  <c:v>28611</c:v>
                 </c:pt>
                 <c:pt idx="2">
-                  <c:v>45607</c:v>
+                  <c:v>57535</c:v>
                 </c:pt>
               </c:numCache>
             </c:numRef>
@@ -832,8 +832,8 @@
             <a:r>
               <a:rPr lang="en-US" dirty="0"/>
               <a:t>[4:00–4:18]
-We run lean: three founders who hold equity, AI-assisted development, and cloud servers that cost about 50 dollars a month at launch. Counting subscriptions only, revenue reaches 68,000 dollars in Year 3, we turn profitable in Year 2, and we break even at about 670 paying shops — around 1% of the stores we target. Marketplace commission is upside on top.
-(Q&amp;A: founders take a small allowance, $100 rising to $500 a month; even at a $1,000 market salary, Year 3 is still about +$7.7K. We need about $3.8K before we turn profitable. Model: docs/rentify-financial-model.xlsx.)</a:t>
+We run lean: five founders who hold equity, AI-assisted development, and cloud servers that cost about 50 dollars a month at launch. Counting subscriptions only and after VAT and taxes, revenue reaches 62,000 dollars in Year 3 and we turn profitable that year, breaking even at about 1,040 paying shops — under 2% of the stores we target. With a 3% marketplace commission, Year 3 profit rises to about 20,000 dollars.
+(Q&amp;A: founders take a small allowance, $100 rising to $500 a month. We need about $13.8K before we turn profitable — prize money, grants and savings. Taxes: 10% VAT is included in our $5 price; 20% profit tax only once past losses are used up. Model: docs/rentify-financial-model.xlsx.)</a:t>
             </a:r>
             <a:endParaRPr lang="en-US" dirty="0"/>
           </a:p>
@@ -1278,7 +1278,7 @@
                 <a:ea typeface="Arial" pitchFamily="34" charset="-122"/>
                 <a:cs typeface="Arial" pitchFamily="34" charset="-120"/>
               </a:rPr>
-              <a:t>Base case: subscriptions only, founders on equity · commission is upside</a:t>
+              <a:t>Base case: subscriptions only, 5 founders on equity, after VAT and taxes · commission is upside</a:t>
             </a:r>
             <a:endParaRPr lang="en-US" sz="1500" dirty="0"/>
           </a:p>
@@ -1389,7 +1389,7 @@
                 <a:ea typeface="Arial" pitchFamily="34" charset="-122"/>
                 <a:cs typeface="Arial" pitchFamily="34" charset="-120"/>
               </a:rPr>
-              <a:t>$67.7K</a:t>
+              <a:t>$61.6K</a:t>
             </a:r>
             <a:endParaRPr lang="en-US" sz="2600" dirty="0"/>
           </a:p>
@@ -1428,7 +1428,7 @@
                 <a:ea typeface="Arial" pitchFamily="34" charset="-122"/>
                 <a:cs typeface="Arial" pitchFamily="34" charset="-120"/>
               </a:rPr>
-              <a:t>Year 3 revenue</a:t>
+              <a:t>Year 3 revenue after 10% VAT</a:t>
             </a:r>
             <a:endParaRPr lang="en-US" sz="1300" dirty="0"/>
           </a:p>
@@ -1489,7 +1489,7 @@
                 <a:ea typeface="Arial" pitchFamily="34" charset="-122"/>
                 <a:cs typeface="Arial" pitchFamily="34" charset="-120"/>
               </a:rPr>
-              <a:t>Year 2</a:t>
+              <a:t>Year 3</a:t>
             </a:r>
             <a:endParaRPr lang="en-US" sz="2600" dirty="0"/>
           </a:p>
@@ -1528,7 +1528,7 @@
                 <a:ea typeface="Arial" pitchFamily="34" charset="-122"/>
                 <a:cs typeface="Arial" pitchFamily="34" charset="-120"/>
               </a:rPr>
-              <a:t>first profit: +$6.1K</a:t>
+              <a:t>first profit: +$4.1K</a:t>
             </a:r>
             <a:endParaRPr lang="en-US" sz="1300" dirty="0"/>
           </a:p>
@@ -1589,7 +1589,7 @@
                 <a:ea typeface="Arial" pitchFamily="34" charset="-122"/>
                 <a:cs typeface="Arial" pitchFamily="34" charset="-120"/>
               </a:rPr>
-              <a:t>~670</a:t>
+              <a:t>~1,040</a:t>
             </a:r>
             <a:endParaRPr lang="en-US" sz="2600" dirty="0"/>
           </a:p>
@@ -1628,7 +1628,7 @@
                 <a:ea typeface="Arial" pitchFamily="34" charset="-122"/>
                 <a:cs typeface="Arial" pitchFamily="34" charset="-120"/>
               </a:rPr>
-              <a:t>paying shops to break even (1% of our market)</a:t>
+              <a:t>paying shops to break even (1.6% of our market)</a:t>
             </a:r>
             <a:endParaRPr lang="en-US" sz="1300" dirty="0"/>
           </a:p>
@@ -1689,7 +1689,7 @@
                 <a:ea typeface="Arial" pitchFamily="34" charset="-122"/>
                 <a:cs typeface="Arial" pitchFamily="34" charset="-120"/>
               </a:rPr>
-              <a:t>$3.8K</a:t>
+              <a:t>$13.8K</a:t>
             </a:r>
             <a:endParaRPr lang="en-US" sz="2600" dirty="0"/>
           </a:p>
@@ -1767,7 +1767,7 @@
                 <a:ea typeface="Arial" pitchFamily="34" charset="-122"/>
                 <a:cs typeface="Arial" pitchFamily="34" charset="-120"/>
               </a:rPr>
-              <a:t>Net result −$3.8K, +$6.1K, +$22.1K (Years 1–3). With 3% marketplace commission: −$3.5K, +$10.6K, +$38.4K. Costs priced bottom-up (DigitalOcean, Resend, MoC fees); shop numbers from the team model. Full detail in appendix; all inputs to validate in the pilot.</a:t>
+              <a:t>Net result −$8.1K, −$5.8K, +$4.1K (Years 1–3). With 3% marketplace commission: −$7.8K, −$0.8K, +$19.9K. Includes 10% VAT, 1% tax prepayment, patent tax, NSSF and 14% withholding on foreign services. Full detail in appendix; all inputs to validate in the pilot.</a:t>
             </a:r>
             <a:endParaRPr lang="en-US" sz="950" dirty="0"/>
           </a:p>

</xml_diff>

<commit_message>
Rework financial model for a bootstrapped five-person team
Model v4: the team is unpaid in Year 1, then takes half of each year's
profit (max $500 per founder a month); marketing is 10% of revenue plus
referral credits; shared AI tools, no office rent, no hires, accountant
from Year 3. Projection slide now shows where each year's revenue goes.
Add bootstrapped benchmarks and caveats to docs/research.md.

Co-Authored-By: Claude Opus 5.5 <noreply@anthropic.com>
Claude-Session: https://claude.ai/code/session_01MF4S689Cu66DaEpymoVfar
</commit_message>
<xml_diff>
--- a/output/drafts/Rentify_v6_slide12_projection.pptx
+++ b/output/drafts/Rentify_v6_slide12_projection.pptx
@@ -112,12 +112,41 @@
   <c:date1904 val="0"/>
   <c:roundedCorners val="1"/>
   <c:chart>
-    <c:autoTitleDeleted val="1"/>
+    <c:title>
+      <c:tx>
+        <c:rich>
+          <a:bodyPr/>
+          <a:lstStyle/>
+          <a:p>
+            <a:pPr>
+              <a:defRPr sz="1300" b="0" i="0" u="none" strike="noStrike">
+                <a:solidFill>
+                  <a:srgbClr val="52637A"/>
+                </a:solidFill>
+                <a:latin typeface="Arial"/>
+              </a:defRPr>
+            </a:pPr>
+            <a:r>
+              <a:rPr sz="1300" b="0" i="0" u="none" strike="noStrike">
+                <a:solidFill>
+                  <a:srgbClr val="52637A"/>
+                </a:solidFill>
+                <a:latin typeface="Arial"/>
+              </a:rPr>
+              <a:t>Where each year's revenue goes</a:t>
+            </a:r>
+          </a:p>
+        </c:rich>
+      </c:tx>
+      <c:layout/>
+      <c:overlay val="0"/>
+    </c:title>
+    <c:autoTitleDeleted val="0"/>
     <c:plotArea>
       <c:layout/>
       <c:barChart>
         <c:barDir val="col"/>
-        <c:grouping val="clustered"/>
+        <c:grouping val="stacked"/>
         <c:varyColors val="0"/>
         <c:ser>
           <c:idx val="0"/>
@@ -128,20 +157,20 @@
               <c:strCache>
                 <c:ptCount val="1"/>
                 <c:pt idx="0">
-                  <c:v>Revenue</c:v>
+                  <c:v>Running costs + tax</c:v>
                 </c:pt>
               </c:strCache>
             </c:strRef>
           </c:tx>
           <c:spPr>
             <a:solidFill>
-              <a:srgbClr val="0AA7A2"/>
+              <a:srgbClr val="64748B"/>
             </a:solidFill>
             <a:effectLst/>
           </c:spPr>
           <c:invertIfNegative val="0"/>
           <c:dLbls>
-            <c:numFmt formatCode="$#,##0" sourceLinked="0"/>
+            <c:numFmt formatCode="[&gt;=1000]$#,##0;&quot;&quot;" sourceLinked="0"/>
             <c:txPr>
               <a:bodyPr/>
               <a:lstStyle/>
@@ -149,13 +178,14 @@
                 <a:pPr>
                   <a:defRPr b="0" i="0" strike="noStrike" sz="1100" u="none">
                     <a:solidFill>
-                      <a:srgbClr val="15243A"/>
+                      <a:srgbClr val="FFFFFF"/>
                     </a:solidFill>
                     <a:latin typeface="Arial"/>
                   </a:defRPr>
                 </a:pPr>
               </a:p>
             </c:txPr>
+            <c:dLblPos val="ctr"/>
             <c:showLegendKey val="0"/>
             <c:showVal val="1"/>
             <c:showCatName val="0"/>
@@ -190,13 +220,13 @@
                 <c:formatCode>General</c:formatCode>
                 <c:ptCount val="3"/>
                 <c:pt idx="0">
-                  <c:v>3142</c:v>
+                  <c:v>2905</c:v>
                 </c:pt>
                 <c:pt idx="1">
-                  <c:v>22846</c:v>
+                  <c:v>6734</c:v>
                 </c:pt>
                 <c:pt idx="2">
-                  <c:v>61586</c:v>
+                  <c:v>16251</c:v>
                 </c:pt>
               </c:numCache>
             </c:numRef>
@@ -211,20 +241,20 @@
               <c:strCache>
                 <c:ptCount val="1"/>
                 <c:pt idx="0">
-                  <c:v>Total cost</c:v>
+                  <c:v>Team pay (from profit)</c:v>
                 </c:pt>
               </c:strCache>
             </c:strRef>
           </c:tx>
           <c:spPr>
             <a:solidFill>
-              <a:srgbClr val="C7D2E0"/>
+              <a:srgbClr val="2463E8"/>
             </a:solidFill>
             <a:effectLst/>
           </c:spPr>
           <c:invertIfNegative val="0"/>
           <c:dLbls>
-            <c:numFmt formatCode="$#,##0" sourceLinked="0"/>
+            <c:numFmt formatCode="[&gt;=1000]$#,##0;&quot;&quot;" sourceLinked="0"/>
             <c:txPr>
               <a:bodyPr/>
               <a:lstStyle/>
@@ -232,13 +262,14 @@
                 <a:pPr>
                   <a:defRPr b="0" i="0" strike="noStrike" sz="1100" u="none">
                     <a:solidFill>
-                      <a:srgbClr val="15243A"/>
+                      <a:srgbClr val="FFFFFF"/>
                     </a:solidFill>
                     <a:latin typeface="Arial"/>
                   </a:defRPr>
                 </a:pPr>
               </a:p>
             </c:txPr>
+            <c:dLblPos val="ctr"/>
             <c:showLegendKey val="0"/>
             <c:showVal val="1"/>
             <c:showCatName val="0"/>
@@ -273,20 +304,104 @@
                 <c:formatCode>General</c:formatCode>
                 <c:ptCount val="3"/>
                 <c:pt idx="0">
-                  <c:v>11212</c:v>
+                  <c:v>0</c:v>
                 </c:pt>
                 <c:pt idx="1">
-                  <c:v>28611</c:v>
+                  <c:v>9426</c:v>
                 </c:pt>
                 <c:pt idx="2">
-                  <c:v>57535</c:v>
+                  <c:v>26741</c:v>
+                </c:pt>
+              </c:numCache>
+            </c:numRef>
+          </c:val>
+        </c:ser>
+        <c:ser>
+          <c:idx val="2"/>
+          <c:order val="2"/>
+          <c:tx>
+            <c:strRef>
+              <c:f>Sheet1!$D$1</c:f>
+              <c:strCache>
+                <c:ptCount val="1"/>
+                <c:pt idx="0">
+                  <c:v>Kept in the company</c:v>
+                </c:pt>
+              </c:strCache>
+            </c:strRef>
+          </c:tx>
+          <c:spPr>
+            <a:solidFill>
+              <a:srgbClr val="0AA7A2"/>
+            </a:solidFill>
+            <a:effectLst/>
+          </c:spPr>
+          <c:invertIfNegative val="0"/>
+          <c:dLbls>
+            <c:numFmt formatCode="[&gt;=1000]$#,##0;&quot;&quot;" sourceLinked="0"/>
+            <c:txPr>
+              <a:bodyPr/>
+              <a:lstStyle/>
+              <a:p>
+                <a:pPr>
+                  <a:defRPr b="0" i="0" strike="noStrike" sz="1100" u="none">
+                    <a:solidFill>
+                      <a:srgbClr val="FFFFFF"/>
+                    </a:solidFill>
+                    <a:latin typeface="Arial"/>
+                  </a:defRPr>
+                </a:pPr>
+              </a:p>
+            </c:txPr>
+            <c:dLblPos val="ctr"/>
+            <c:showLegendKey val="0"/>
+            <c:showVal val="1"/>
+            <c:showCatName val="0"/>
+            <c:showSerName val="0"/>
+            <c:showPercent val="0"/>
+            <c:showBubbleSize val="0"/>
+            <c:showLeaderLines val="0"/>
+          </c:dLbls>
+          <c:cat>
+            <c:multiLvlStrRef>
+              <c:f>Sheet1!$A$2:$A$4</c:f>
+              <c:multiLvlStrCache>
+                <c:ptCount val="3"/>
+                <c:lvl>
+                  <c:pt idx="0">
+                    <c:v>Year 1</c:v>
+                  </c:pt>
+                  <c:pt idx="1">
+                    <c:v>Year 2</c:v>
+                  </c:pt>
+                  <c:pt idx="2">
+                    <c:v>Year 3</c:v>
+                  </c:pt>
+                </c:lvl>
+              </c:multiLvlStrCache>
+            </c:multiLvlStrRef>
+          </c:cat>
+          <c:val>
+            <c:numRef>
+              <c:f>Sheet1!$D$2:$D$4</c:f>
+              <c:numCache>
+                <c:formatCode>General</c:formatCode>
+                <c:ptCount val="3"/>
+                <c:pt idx="0">
+                  <c:v>236</c:v>
+                </c:pt>
+                <c:pt idx="1">
+                  <c:v>6687</c:v>
+                </c:pt>
+                <c:pt idx="2">
+                  <c:v>18594</c:v>
                 </c:pt>
               </c:numCache>
             </c:numRef>
           </c:val>
         </c:ser>
         <c:dLbls>
-          <c:numFmt formatCode="$#,##0" sourceLinked="0"/>
+          <c:numFmt formatCode="[&gt;=1000]$#,##0;&quot;&quot;" sourceLinked="0"/>
           <c:txPr>
             <a:bodyPr/>
             <a:lstStyle/>
@@ -294,13 +409,14 @@
               <a:pPr>
                 <a:defRPr b="0" i="0" strike="noStrike" sz="1100" u="none">
                   <a:solidFill>
-                    <a:srgbClr val="15243A"/>
+                    <a:srgbClr val="FFFFFF"/>
                   </a:solidFill>
                   <a:latin typeface="Arial"/>
                 </a:defRPr>
               </a:pPr>
             </a:p>
           </c:txPr>
+          <c:dLblPos val="ctr"/>
           <c:showLegendKey val="0"/>
           <c:showVal val="1"/>
           <c:showCatName val="0"/>
@@ -309,8 +425,8 @@
           <c:showBubbleSize val="0"/>
           <c:showLeaderLines val="0"/>
         </c:dLbls>
-        <c:gapWidth val="60"/>
-        <c:overlap val="0"/>
+        <c:gapWidth val="55"/>
+        <c:overlap val="100"/>
         <c:axId val="2094734554"/>
         <c:axId val="2094734552"/>
         <c:axId val="2094734556"/>
@@ -832,8 +948,8 @@
             <a:r>
               <a:rPr lang="en-US" dirty="0"/>
               <a:t>[4:00–4:18]
-We run lean: five founders who hold equity, AI-assisted development, and cloud servers that cost about 50 dollars a month at launch. Counting subscriptions only and after VAT and taxes, revenue reaches 62,000 dollars in Year 3 and we turn profitable that year, breaking even at about 1,040 paying shops — under 2% of the stores we target. With a 3% marketplace commission, Year 3 profit rises to about 20,000 dollars.
-(Q&amp;A: founders take a small allowance, $100 rising to $500 a month. We need about $13.8K before we turn profitable — prize money, grants and savings. Taxes: 10% VAT is included in our $5 price; 20% profit tax only once past losses are used up. Model: docs/rentify-financial-model.xlsx.)</a:t>
+We are bootstrapped. Five founders do everything themselves, with AI-assisted development and servers that cost about 50 dollars a month. About 110 paying shops cover all our running costs, so Rentify pays for itself from Year 1. We work unpaid that year, then pay ourselves from profit: about 150 dollars a month each in Year 2 and 420 in Year 3, while still keeping 18,600 dollars in the company. Marketplace commission is upside on top.
+(Q&amp;A: rule = half of each year's profit goes to the team, capped at $500 per founder; the rest is reserve. Marketing is 10% of revenue; growth is founder-led. We need about $1.1K to start: registration and pilot servers. About 765 paying shops would pay all five of us the full $500. Model: docs/rentify-financial-model.xlsx.)</a:t>
             </a:r>
             <a:endParaRPr lang="en-US" dirty="0"/>
           </a:p>
@@ -1278,7 +1394,7 @@
                 <a:ea typeface="Arial" pitchFamily="34" charset="-122"/>
                 <a:cs typeface="Arial" pitchFamily="34" charset="-120"/>
               </a:rPr>
-              <a:t>Base case: subscriptions only, 5 founders on equity, after VAT and taxes · commission is upside</a:t>
+              <a:t>Bootstrapped: team unpaid in Year 1, then paid from profit · subscriptions only</a:t>
             </a:r>
             <a:endParaRPr lang="en-US" sz="1500" dirty="0"/>
           </a:p>
@@ -1489,7 +1605,7 @@
                 <a:ea typeface="Arial" pitchFamily="34" charset="-122"/>
                 <a:cs typeface="Arial" pitchFamily="34" charset="-120"/>
               </a:rPr>
-              <a:t>Year 3</a:t>
+              <a:t>Year 1</a:t>
             </a:r>
             <a:endParaRPr lang="en-US" sz="2600" dirty="0"/>
           </a:p>
@@ -1528,7 +1644,7 @@
                 <a:ea typeface="Arial" pitchFamily="34" charset="-122"/>
                 <a:cs typeface="Arial" pitchFamily="34" charset="-120"/>
               </a:rPr>
-              <a:t>first profit: +$4.1K</a:t>
+              <a:t>covers its own costs, team unpaid</a:t>
             </a:r>
             <a:endParaRPr lang="en-US" sz="1300" dirty="0"/>
           </a:p>
@@ -1589,7 +1705,7 @@
                 <a:ea typeface="Arial" pitchFamily="34" charset="-122"/>
                 <a:cs typeface="Arial" pitchFamily="34" charset="-120"/>
               </a:rPr>
-              <a:t>~1,040</a:t>
+              <a:t>~110</a:t>
             </a:r>
             <a:endParaRPr lang="en-US" sz="2600" dirty="0"/>
           </a:p>
@@ -1628,7 +1744,7 @@
                 <a:ea typeface="Arial" pitchFamily="34" charset="-122"/>
                 <a:cs typeface="Arial" pitchFamily="34" charset="-120"/>
               </a:rPr>
-              <a:t>paying shops to break even (1.6% of our market)</a:t>
+              <a:t>paying shops cover all running costs</a:t>
             </a:r>
             <a:endParaRPr lang="en-US" sz="1300" dirty="0"/>
           </a:p>
@@ -1689,7 +1805,7 @@
                 <a:ea typeface="Arial" pitchFamily="34" charset="-122"/>
                 <a:cs typeface="Arial" pitchFamily="34" charset="-120"/>
               </a:rPr>
-              <a:t>$13.8K</a:t>
+              <a:t>$1.1K</a:t>
             </a:r>
             <a:endParaRPr lang="en-US" sz="2600" dirty="0"/>
           </a:p>
@@ -1728,7 +1844,7 @@
                 <a:ea typeface="Arial" pitchFamily="34" charset="-122"/>
                 <a:cs typeface="Arial" pitchFamily="34" charset="-120"/>
               </a:rPr>
-              <a:t>funding needed before profit</a:t>
+              <a:t>cash needed to start</a:t>
             </a:r>
             <a:endParaRPr lang="en-US" sz="1300" dirty="0"/>
           </a:p>
@@ -1767,7 +1883,7 @@
                 <a:ea typeface="Arial" pitchFamily="34" charset="-122"/>
                 <a:cs typeface="Arial" pitchFamily="34" charset="-120"/>
               </a:rPr>
-              <a:t>Net result −$8.1K, −$5.8K, +$4.1K (Years 1–3). With 3% marketplace commission: −$7.8K, −$0.8K, +$19.9K. Includes 10% VAT, 1% tax prepayment, patent tax, NSSF and 14% withholding on foreign services. Full detail in appendix; all inputs to validate in the pilot.</a:t>
+              <a:t>Team pay per founder: $0 → ~$150 → ~$420 a month (half of profit, max $500). With 3% commission the team reaches $500 in Year 3 and $27.0K is kept. After 10% VAT and Cambodian taxes. All inputs to validate in the pilot.</a:t>
             </a:r>
             <a:endParaRPr lang="en-US" sz="950" dirty="0"/>
           </a:p>

</xml_diff>